<commit_message>
Add the Hawnan working prototype and refresh the demo slide
Pure-Python engine (event-sourced batch clock, honest remaining-time
ranges, Ed25519-signed offline batch pass, silent-call fan-out, signed
content packs in 10 languages, batch-event indicators, deterministic
digital twin, HMAC-chained audit), a FastAPI service with per-device
sessions and security headers, and guest / staff / display / ops /
check-in pages that run on a hotspot with no internet. 63 tests pass.
Screenshots feed the deck's live-demo slide. The permit feed is simulated
and declared on every page.

Co-Authored-By: Claude Fable 5.1 <noreply@anthropic.com>
Claude-Session: https://claude.ai/code/session_01EWikEw3xvZq9GhVuFvGZfp
</commit_message>
<xml_diff>
--- a/haramain-2026/pitch/Hawnan_Fakkir_lilHaramain_2026.pptx
+++ b/haramain-2026/pitch/Hawnan_Fakkir_lilHaramain_2026.pptx
@@ -6599,385 +6599,32 @@
           </a:ln>
         </p:spPr>
       </p:sp>
-      <p:sp>
-        <p:nvSpPr>
-          <p:cNvPr id="11" name="Text 9"/>
-          <p:cNvSpPr txBox="1"/>
-          <p:nvPr/>
-        </p:nvSpPr>
-        <p:spPr>
-          <a:xfrm>
-            <a:off x="7004304" y="1719072"/>
-            <a:ext cx="1399032" cy="274320"/>
-          </a:xfrm>
-          <a:prstGeom prst="roundRect">
-            <a:avLst>
-              <a:gd name="adj" fmla="val 50000"/>
-            </a:avLst>
-          </a:prstGeom>
-          <a:solidFill>
-            <a:srgbClr val="006868"/>
-          </a:solidFill>
-          <a:ln/>
-        </p:spPr>
-        <p:txBody>
-          <a:bodyPr wrap="square" lIns="0" tIns="0" rIns="0" bIns="0" rtlCol="0" anchor="ctr"/>
-          <a:lstStyle/>
-          <a:p>
-            <a:pPr algn="ctr" indent="0" marL="0">
-              <a:buNone/>
-            </a:pPr>
-            <a:r>
-              <a:rPr lang="id-ID" altLang="en-US" sz="1000" b="1" dirty="0">
-                <a:solidFill>
-                  <a:srgbClr val="FFFFFF"/>
-                </a:solidFill>
-                <a:latin typeface="Arial" pitchFamily="34" charset="0"/>
-                <a:ea typeface="Arial" pitchFamily="34" charset="-122"/>
-                <a:cs typeface="Arial" pitchFamily="34" charset="-120"/>
-              </a:rPr>
-              <a:t>Rombongan 14</a:t>
-            </a:r>
-            <a:endParaRPr lang="id-ID" sz="1000" dirty="0"/>
-          </a:p>
-        </p:txBody>
-      </p:sp>
-      <p:sp>
-        <p:nvSpPr>
-          <p:cNvPr id="12" name="Text 10"/>
-          <p:cNvSpPr txBox="1"/>
-          <p:nvPr/>
-        </p:nvSpPr>
-        <p:spPr>
-          <a:xfrm>
-            <a:off x="7004304" y="2066544"/>
-            <a:ext cx="1399032" cy="228600"/>
+      <p:pic>
+        <p:nvPicPr>
+          <p:cNvPr id="11" name="Image 0" descr="/home/user/darghaith-samples/haramain-2026/prototype/docs/screenshots/guest-id.png">    </p:cNvPr>
+          <p:cNvPicPr>
+            <a:picLocks noChangeAspect="1"/>
+          </p:cNvPicPr>
+          <p:nvPr/>
+        </p:nvPicPr>
+        <p:blipFill>
+          <a:blip r:embed="rId1"/>
+          <a:srcRect l="0" r="0" t="0" b="0"/>
+          <a:stretch/>
+        </p:blipFill>
+        <p:spPr>
+          <a:xfrm>
+            <a:off x="6894576" y="1609344"/>
+            <a:ext cx="1618488" cy="2606040"/>
           </a:xfrm>
           <a:prstGeom prst="rect">
             <a:avLst/>
           </a:prstGeom>
-          <a:noFill/>
-          <a:ln/>
-        </p:spPr>
-        <p:txBody>
-          <a:bodyPr wrap="square" lIns="0" tIns="0" rIns="0" bIns="0" rtlCol="0" anchor="t"/>
-          <a:lstStyle/>
-          <a:p>
-            <a:pPr algn="l" indent="0" marL="0">
-              <a:buNone/>
-            </a:pPr>
-            <a:r>
-              <a:rPr lang="id-ID" altLang="en-US" sz="750" dirty="0">
-                <a:solidFill>
-                  <a:srgbClr val="505060"/>
-                </a:solidFill>
-                <a:latin typeface="Arial" pitchFamily="34" charset="0"/>
-                <a:ea typeface="Arial" pitchFamily="34" charset="-122"/>
-                <a:cs typeface="Arial" pitchFamily="34" charset="-120"/>
-              </a:rPr>
-              <a:t>Titik tunggu B2 · Perempuan 08:20</a:t>
-            </a:r>
-            <a:endParaRPr lang="id-ID" sz="750" dirty="0"/>
-          </a:p>
-        </p:txBody>
-      </p:sp>
-      <p:sp>
-        <p:nvSpPr>
-          <p:cNvPr id="13" name="Text 11"/>
-          <p:cNvSpPr txBox="1"/>
-          <p:nvPr/>
-        </p:nvSpPr>
-        <p:spPr>
-          <a:xfrm>
-            <a:off x="7004304" y="2340864"/>
-            <a:ext cx="1399032" cy="201168"/>
-          </a:xfrm>
-          <a:prstGeom prst="rect">
-            <a:avLst/>
-          </a:prstGeom>
-          <a:noFill/>
-          <a:ln/>
-        </p:spPr>
-        <p:txBody>
-          <a:bodyPr wrap="square" lIns="0" tIns="0" rIns="0" bIns="0" rtlCol="0" anchor="t"/>
-          <a:lstStyle/>
-          <a:p>
-            <a:pPr algn="ctr" indent="0" marL="0">
-              <a:buNone/>
-            </a:pPr>
-            <a:r>
-              <a:rPr lang="id-ID" altLang="en-US" sz="800" dirty="0">
-                <a:solidFill>
-                  <a:srgbClr val="505060"/>
-                </a:solidFill>
-                <a:latin typeface="Arial" pitchFamily="34" charset="0"/>
-                <a:ea typeface="Arial" pitchFamily="34" charset="-122"/>
-                <a:cs typeface="Arial" pitchFamily="34" charset="-120"/>
-              </a:rPr>
-              <a:t>sekitar</a:t>
-            </a:r>
-            <a:endParaRPr lang="id-ID" sz="800" dirty="0"/>
-          </a:p>
-        </p:txBody>
-      </p:sp>
-      <p:sp>
-        <p:nvSpPr>
-          <p:cNvPr id="14" name="Text 12"/>
-          <p:cNvSpPr txBox="1"/>
-          <p:nvPr/>
-        </p:nvSpPr>
-        <p:spPr>
-          <a:xfrm>
-            <a:off x="7004304" y="2523744"/>
-            <a:ext cx="1399032" cy="457200"/>
-          </a:xfrm>
-          <a:prstGeom prst="rect">
-            <a:avLst/>
-          </a:prstGeom>
-          <a:noFill/>
-          <a:ln/>
-        </p:spPr>
-        <p:txBody>
-          <a:bodyPr wrap="square" lIns="0" tIns="0" rIns="0" bIns="0" rtlCol="0" anchor="ctr"/>
-          <a:lstStyle/>
-          <a:p>
-            <a:pPr algn="ctr" indent="0" marL="0">
-              <a:buNone/>
-            </a:pPr>
-            <a:r>
-              <a:rPr lang="en-US" altLang="en-US" sz="2600" b="1" dirty="0">
-                <a:solidFill>
-                  <a:srgbClr val="006868"/>
-                </a:solidFill>
-                <a:latin typeface="Arial" pitchFamily="34" charset="0"/>
-                <a:ea typeface="Arial" pitchFamily="34" charset="-122"/>
-                <a:cs typeface="Arial" pitchFamily="34" charset="-120"/>
-              </a:rPr>
-              <a:t>12–18</a:t>
-            </a:r>
-            <a:endParaRPr lang="en-US" sz="2600" dirty="0"/>
-          </a:p>
-        </p:txBody>
-      </p:sp>
-      <p:sp>
-        <p:nvSpPr>
-          <p:cNvPr id="15" name="Text 13"/>
-          <p:cNvSpPr txBox="1"/>
-          <p:nvPr/>
-        </p:nvSpPr>
-        <p:spPr>
-          <a:xfrm>
-            <a:off x="7004304" y="2980944"/>
-            <a:ext cx="1399032" cy="201168"/>
-          </a:xfrm>
-          <a:prstGeom prst="rect">
-            <a:avLst/>
-          </a:prstGeom>
-          <a:noFill/>
-          <a:ln/>
-        </p:spPr>
-        <p:txBody>
-          <a:bodyPr wrap="square" lIns="0" tIns="0" rIns="0" bIns="0" rtlCol="0" anchor="t"/>
-          <a:lstStyle/>
-          <a:p>
-            <a:pPr algn="ctr" indent="0" marL="0">
-              <a:buNone/>
-            </a:pPr>
-            <a:r>
-              <a:rPr lang="id-ID" altLang="en-US" sz="800" dirty="0">
-                <a:solidFill>
-                  <a:srgbClr val="505060"/>
-                </a:solidFill>
-                <a:latin typeface="Arial" pitchFamily="34" charset="0"/>
-                <a:ea typeface="Arial" pitchFamily="34" charset="-122"/>
-                <a:cs typeface="Arial" pitchFamily="34" charset="-120"/>
-              </a:rPr>
-              <a:t>menit</a:t>
-            </a:r>
-            <a:endParaRPr lang="id-ID" sz="800" dirty="0"/>
-          </a:p>
-        </p:txBody>
-      </p:sp>
-      <p:sp>
-        <p:nvSpPr>
-          <p:cNvPr id="16" name="Shape 14"/>
-          <p:cNvSpPr/>
-          <p:nvPr/>
-        </p:nvSpPr>
-        <p:spPr>
-          <a:xfrm>
-            <a:off x="7004304" y="3255264"/>
-            <a:ext cx="1399032" cy="566928"/>
-          </a:xfrm>
-          <a:prstGeom prst="roundRect">
-            <a:avLst>
-              <a:gd name="adj" fmla="val 12903"/>
-            </a:avLst>
-          </a:prstGeom>
-          <a:solidFill>
-            <a:srgbClr val="E9F4F1"/>
-          </a:solidFill>
-          <a:ln w="12700">
-            <a:solidFill>
-              <a:srgbClr val="E9F4F1"/>
-            </a:solidFill>
-            <a:prstDash val="solid"/>
-          </a:ln>
-        </p:spPr>
-      </p:sp>
-      <p:sp>
-        <p:nvSpPr>
-          <p:cNvPr id="17" name="Shape 15"/>
-          <p:cNvSpPr/>
-          <p:nvPr/>
-        </p:nvSpPr>
-        <p:spPr>
-          <a:xfrm>
-            <a:off x="7077456" y="3374136"/>
-            <a:ext cx="329184" cy="329184"/>
-          </a:xfrm>
-          <a:prstGeom prst="ellipse">
-            <a:avLst/>
-          </a:prstGeom>
-          <a:solidFill>
-            <a:srgbClr val="78C0B0"/>
-          </a:solidFill>
-          <a:ln w="12700">
-            <a:solidFill>
-              <a:srgbClr val="78C0B0"/>
-            </a:solidFill>
-            <a:prstDash val="solid"/>
-          </a:ln>
-        </p:spPr>
-      </p:sp>
-      <p:sp>
-        <p:nvSpPr>
-          <p:cNvPr id="18" name="Text 16"/>
-          <p:cNvSpPr txBox="1"/>
-          <p:nvPr/>
-        </p:nvSpPr>
-        <p:spPr>
-          <a:xfrm>
-            <a:off x="7461504" y="3310128"/>
-            <a:ext cx="923544" cy="182880"/>
-          </a:xfrm>
-          <a:prstGeom prst="rect">
-            <a:avLst/>
-          </a:prstGeom>
-          <a:noFill/>
-          <a:ln/>
-        </p:spPr>
-        <p:txBody>
-          <a:bodyPr wrap="square" lIns="0" tIns="0" rIns="0" bIns="0" rtlCol="0" anchor="t"/>
-          <a:lstStyle/>
-          <a:p>
-            <a:pPr algn="l" indent="0" marL="0">
-              <a:buNone/>
-            </a:pPr>
-            <a:r>
-              <a:rPr lang="id-ID" altLang="en-US" sz="650" dirty="0">
-                <a:solidFill>
-                  <a:srgbClr val="505060"/>
-                </a:solidFill>
-                <a:latin typeface="Arial" pitchFamily="34" charset="0"/>
-                <a:ea typeface="Arial" pitchFamily="34" charset="-122"/>
-                <a:cs typeface="Arial" pitchFamily="34" charset="-120"/>
-              </a:rPr>
-              <a:t>Instruksi petugas</a:t>
-            </a:r>
-            <a:endParaRPr lang="id-ID" sz="650" dirty="0"/>
-          </a:p>
-        </p:txBody>
-      </p:sp>
-      <p:sp>
-        <p:nvSpPr>
-          <p:cNvPr id="19" name="Text 17"/>
-          <p:cNvSpPr txBox="1"/>
-          <p:nvPr/>
-        </p:nvSpPr>
-        <p:spPr>
-          <a:xfrm>
-            <a:off x="7461504" y="3483864"/>
-            <a:ext cx="923544" cy="274320"/>
-          </a:xfrm>
-          <a:prstGeom prst="rect">
-            <a:avLst/>
-          </a:prstGeom>
-          <a:noFill/>
-          <a:ln/>
-        </p:spPr>
-        <p:txBody>
-          <a:bodyPr wrap="square" lIns="0" tIns="0" rIns="0" bIns="0" rtlCol="0" anchor="t"/>
-          <a:lstStyle/>
-          <a:p>
-            <a:pPr algn="l" indent="0" marL="0">
-              <a:buNone/>
-            </a:pPr>
-            <a:r>
-              <a:rPr lang="id-ID" altLang="en-US" sz="1000" b="1" dirty="0">
-                <a:solidFill>
-                  <a:srgbClr val="006868"/>
-                </a:solidFill>
-                <a:latin typeface="Arial" pitchFamily="34" charset="0"/>
-                <a:ea typeface="Arial" pitchFamily="34" charset="-122"/>
-                <a:cs typeface="Arial" pitchFamily="34" charset="-120"/>
-              </a:rPr>
-              <a:t>Silakan duduk</a:t>
-            </a:r>
-            <a:endParaRPr lang="id-ID" sz="1000" dirty="0"/>
-          </a:p>
-        </p:txBody>
-      </p:sp>
-      <p:sp>
-        <p:nvSpPr>
-          <p:cNvPr id="20" name="Text 18"/>
-          <p:cNvSpPr txBox="1"/>
-          <p:nvPr/>
-        </p:nvSpPr>
-        <p:spPr>
-          <a:xfrm>
-            <a:off x="7004304" y="3913632"/>
-            <a:ext cx="1399032" cy="246888"/>
-          </a:xfrm>
-          <a:prstGeom prst="roundRect">
-            <a:avLst>
-              <a:gd name="adj" fmla="val 50000"/>
-            </a:avLst>
-          </a:prstGeom>
-          <a:solidFill>
-            <a:srgbClr val="FFFFFF"/>
-          </a:solidFill>
-          <a:ln w="12700">
-            <a:solidFill>
-              <a:srgbClr val="006868"/>
-            </a:solidFill>
-          </a:ln>
-        </p:spPr>
-        <p:txBody>
-          <a:bodyPr wrap="square" lIns="0" tIns="0" rIns="0" bIns="0" rtlCol="0" anchor="ctr"/>
-          <a:lstStyle/>
-          <a:p>
-            <a:pPr algn="ctr" indent="0" marL="0">
-              <a:buNone/>
-            </a:pPr>
-            <a:r>
-              <a:rPr lang="id-ID" altLang="en-US" sz="750" dirty="0">
-                <a:solidFill>
-                  <a:srgbClr val="006868"/>
-                </a:solidFill>
-                <a:latin typeface="Arial" pitchFamily="34" charset="0"/>
-                <a:ea typeface="Arial" pitchFamily="34" charset="-122"/>
-                <a:cs typeface="Arial" pitchFamily="34" charset="-120"/>
-              </a:rPr>
-              <a:t>Tunjukkan ke petugas</a:t>
-            </a:r>
-            <a:endParaRPr lang="id-ID" sz="750" dirty="0"/>
-          </a:p>
-        </p:txBody>
-      </p:sp>
-      <p:sp>
-        <p:nvSpPr>
-          <p:cNvPr id="21" name="Shape 19"/>
+        </p:spPr>
+      </p:pic>
+      <p:sp>
+        <p:nvSpPr>
+          <p:cNvPr id="12" name="Shape 9"/>
           <p:cNvSpPr/>
           <p:nvPr/>
         </p:nvSpPr>
@@ -7011,7 +6658,7 @@
       </p:sp>
       <p:sp>
         <p:nvSpPr>
-          <p:cNvPr id="22" name="Shape 20"/>
+          <p:cNvPr id="13" name="Shape 10"/>
           <p:cNvSpPr/>
           <p:nvPr/>
         </p:nvSpPr>
@@ -7038,7 +6685,7 @@
       </p:sp>
       <p:sp>
         <p:nvSpPr>
-          <p:cNvPr id="23" name="Shape 21"/>
+          <p:cNvPr id="14" name="Shape 11"/>
           <p:cNvSpPr/>
           <p:nvPr/>
         </p:nvSpPr>
@@ -7065,7 +6712,7 @@
       </p:sp>
       <p:sp>
         <p:nvSpPr>
-          <p:cNvPr id="24" name="Shape 22"/>
+          <p:cNvPr id="15" name="Shape 12"/>
           <p:cNvSpPr/>
           <p:nvPr/>
         </p:nvSpPr>
@@ -7092,7 +6739,7 @@
       </p:sp>
       <p:sp>
         <p:nvSpPr>
-          <p:cNvPr id="25" name="Text 23"/>
+          <p:cNvPr id="16" name="Text 13"/>
           <p:cNvSpPr txBox="1"/>
           <p:nvPr/>
         </p:nvSpPr>
@@ -7135,7 +6782,7 @@
       </p:sp>
       <p:sp>
         <p:nvSpPr>
-          <p:cNvPr id="26" name="Text 24"/>
+          <p:cNvPr id="17" name="Text 14"/>
           <p:cNvSpPr txBox="1"/>
           <p:nvPr/>
         </p:nvSpPr>
@@ -7174,7 +6821,7 @@
       </p:sp>
       <p:sp>
         <p:nvSpPr>
-          <p:cNvPr id="27" name="Text 25"/>
+          <p:cNvPr id="18" name="Text 15"/>
           <p:cNvSpPr txBox="1"/>
           <p:nvPr/>
         </p:nvSpPr>
@@ -7213,7 +6860,7 @@
       </p:sp>
       <p:sp>
         <p:nvSpPr>
-          <p:cNvPr id="28" name="Text 26"/>
+          <p:cNvPr id="19" name="Text 16"/>
           <p:cNvSpPr txBox="1"/>
           <p:nvPr/>
         </p:nvSpPr>
@@ -7252,7 +6899,7 @@
       </p:sp>
       <p:sp>
         <p:nvSpPr>
-          <p:cNvPr id="29" name="Text 27"/>
+          <p:cNvPr id="20" name="Text 17"/>
           <p:cNvSpPr txBox="1"/>
           <p:nvPr/>
         </p:nvSpPr>
@@ -7291,7 +6938,7 @@
       </p:sp>
       <p:sp>
         <p:nvSpPr>
-          <p:cNvPr id="30" name="Shape 28"/>
+          <p:cNvPr id="21" name="Shape 18"/>
           <p:cNvSpPr/>
           <p:nvPr/>
         </p:nvSpPr>
@@ -7318,7 +6965,7 @@
       </p:sp>
       <p:sp>
         <p:nvSpPr>
-          <p:cNvPr id="31" name="Shape 29"/>
+          <p:cNvPr id="22" name="Shape 19"/>
           <p:cNvSpPr/>
           <p:nvPr/>
         </p:nvSpPr>
@@ -7343,7 +6990,7 @@
       </p:sp>
       <p:sp>
         <p:nvSpPr>
-          <p:cNvPr id="32" name="Text 30"/>
+          <p:cNvPr id="23" name="Text 20"/>
           <p:cNvSpPr txBox="1"/>
           <p:nvPr/>
         </p:nvSpPr>
@@ -7382,7 +7029,7 @@
       </p:sp>
       <p:sp>
         <p:nvSpPr>
-          <p:cNvPr id="33" name="Text 31"/>
+          <p:cNvPr id="24" name="Text 21"/>
           <p:cNvSpPr txBox="1"/>
           <p:nvPr/>
         </p:nvSpPr>
@@ -7421,7 +7068,7 @@
       </p:sp>
       <p:sp>
         <p:nvSpPr>
-          <p:cNvPr id="34" name="Text 32"/>
+          <p:cNvPr id="25" name="Text 22"/>
           <p:cNvSpPr txBox="1"/>
           <p:nvPr/>
         </p:nvSpPr>
@@ -7468,7 +7115,7 @@
       </p:sp>
       <p:sp>
         <p:nvSpPr>
-          <p:cNvPr id="35" name="Shape 33"/>
+          <p:cNvPr id="26" name="Shape 23"/>
           <p:cNvSpPr/>
           <p:nvPr/>
         </p:nvSpPr>
@@ -7502,7 +7149,7 @@
       </p:sp>
       <p:sp>
         <p:nvSpPr>
-          <p:cNvPr id="36" name="Shape 34"/>
+          <p:cNvPr id="27" name="Shape 24"/>
           <p:cNvSpPr/>
           <p:nvPr/>
         </p:nvSpPr>
@@ -7529,7 +7176,7 @@
       </p:sp>
       <p:sp>
         <p:nvSpPr>
-          <p:cNvPr id="37" name="Shape 35"/>
+          <p:cNvPr id="28" name="Shape 25"/>
           <p:cNvSpPr/>
           <p:nvPr/>
         </p:nvSpPr>
@@ -7554,7 +7201,7 @@
       </p:sp>
       <p:sp>
         <p:nvSpPr>
-          <p:cNvPr id="38" name="Text 36"/>
+          <p:cNvPr id="29" name="Text 26"/>
           <p:cNvSpPr txBox="1"/>
           <p:nvPr/>
         </p:nvSpPr>
@@ -7593,7 +7240,7 @@
       </p:sp>
       <p:sp>
         <p:nvSpPr>
-          <p:cNvPr id="39" name="Text 37"/>
+          <p:cNvPr id="30" name="Text 27"/>
           <p:cNvSpPr txBox="1"/>
           <p:nvPr/>
         </p:nvSpPr>
@@ -7636,7 +7283,7 @@
       </p:sp>
       <p:sp>
         <p:nvSpPr>
-          <p:cNvPr id="40" name="Text 38"/>
+          <p:cNvPr id="31" name="Text 28"/>
           <p:cNvSpPr txBox="1"/>
           <p:nvPr/>
         </p:nvSpPr>
@@ -7683,7 +7330,7 @@
       </p:sp>
       <p:sp>
         <p:nvSpPr>
-          <p:cNvPr id="41" name="Text 39"/>
+          <p:cNvPr id="32" name="Text 29"/>
           <p:cNvSpPr txBox="1"/>
           <p:nvPr/>
         </p:nvSpPr>
@@ -7730,7 +7377,7 @@
       </p:sp>
       <p:sp>
         <p:nvSpPr>
-          <p:cNvPr id="42" name="Text 40"/>
+          <p:cNvPr id="33" name="Text 30"/>
           <p:cNvSpPr txBox="1"/>
           <p:nvPr/>
         </p:nvSpPr>
@@ -7777,7 +7424,7 @@
       </p:sp>
       <p:sp>
         <p:nvSpPr>
-          <p:cNvPr id="43" name="Text 41"/>
+          <p:cNvPr id="34" name="Text 31"/>
           <p:cNvSpPr txBox="1"/>
           <p:nvPr/>
         </p:nvSpPr>
@@ -7816,7 +7463,7 @@
       </p:sp>
       <p:sp>
         <p:nvSpPr>
-          <p:cNvPr id="44" name="Text 42"/>
+          <p:cNvPr id="35" name="Text 32"/>
           <p:cNvSpPr txBox="1"/>
           <p:nvPr/>
         </p:nvSpPr>
@@ -7855,7 +7502,7 @@
       </p:sp>
       <p:sp>
         <p:nvSpPr>
-          <p:cNvPr id="45" name="Text 43"/>
+          <p:cNvPr id="36" name="Text 33"/>
           <p:cNvSpPr txBox="1"/>
           <p:nvPr/>
         </p:nvSpPr>
@@ -7894,7 +7541,7 @@
       </p:sp>
       <p:sp>
         <p:nvSpPr>
-          <p:cNvPr id="46" name="Text 44"/>
+          <p:cNvPr id="37" name="Text 34"/>
           <p:cNvSpPr txBox="1"/>
           <p:nvPr/>
         </p:nvSpPr>

</xml_diff>